<commit_message>
fix: handle grouped images and absolute relationship targets
- Recursively collect p:pic elements from p:grpSp groups, not just
  top-level shapes. Grouped images (common after users group objects
  in PowerPoint) were previously skipped entirely.
- Handle package-absolute relationship targets (e.g. /ppt/media/image1.png)
  in addition to relative targets. Previously these resolved to invalid
  zip paths and were silently dropped.
- Update test fixture with a grouped image (slide 4)
- Add 2 regression tests for grouped image extraction

Co-Authored-By: Claude Opus 4.6 (1M context) <noreply@anthropic.com>
</commit_message>
<xml_diff>
--- a/src/converters/fixtures/test-slides.pptx
+++ b/src/converters/fixtures/test-slides.pptx
@@ -8,6 +8,7 @@
     <p:sldId id="256" r:id="rId7"/>
     <p:sldId id="257" r:id="rId8"/>
     <p:sldId id="258" r:id="rId10"/>
+    <p:sldId id="259" r:id="rId11"/>
   </p:sldIdLst>
   <p:sldSz cx="12191695" cy="6858000" type="screen4x3"/>
   <p:notesSz cx="6858000" cy="9144000"/>
@@ -3632,7 +3633,7 @@
         <p:spPr>
           <a:xfrm>
             <a:off x="1828800" y="1828800"/>
-            <a:ext cx="2743200" cy="2743200"/>
+            <a:ext cx="1828800" cy="1828800"/>
           </a:xfrm>
           <a:prstGeom prst="rect">
             <a:avLst/>
@@ -3719,13 +3720,115 @@
         <p:spPr>
           <a:xfrm>
             <a:off x="1828800" y="1828800"/>
-            <a:ext cx="2743200" cy="2743200"/>
+            <a:ext cx="1828800" cy="1828800"/>
           </a:xfrm>
           <a:prstGeom prst="rect">
             <a:avLst/>
           </a:prstGeom>
         </p:spPr>
       </p:pic>
+    </p:spTree>
+  </p:cSld>
+  <p:clrMapOvr>
+    <a:masterClrMapping/>
+  </p:clrMapOvr>
+</p:sld>
+</file>
+
+<file path=ppt/slides/slide4.xml><?xml version="1.0" encoding="utf-8"?>
+<p:sld xmlns:a="http://schemas.openxmlformats.org/drawingml/2006/main" xmlns:p="http://schemas.openxmlformats.org/presentationml/2006/main" xmlns:r="http://schemas.openxmlformats.org/officeDocument/2006/relationships">
+  <p:cSld>
+    <p:spTree>
+      <p:nvGrpSpPr>
+        <p:cNvPr id="1" name=""/>
+        <p:cNvGrpSpPr/>
+        <p:nvPr/>
+      </p:nvGrpSpPr>
+      <p:grpSpPr/>
+      <p:sp>
+        <p:nvSpPr>
+          <p:cNvPr id="2" name="Title 1"/>
+          <p:cNvSpPr>
+            <a:spLocks noGrp="1"/>
+          </p:cNvSpPr>
+          <p:nvPr>
+            <p:ph type="title"/>
+          </p:nvPr>
+        </p:nvSpPr>
+        <p:spPr/>
+        <p:txBody>
+          <a:bodyPr/>
+          <a:lstStyle/>
+          <a:p/>
+        </p:txBody>
+      </p:sp>
+      <p:sp>
+        <p:nvSpPr>
+          <p:cNvPr id="3" name="TextBox 2"/>
+          <p:cNvSpPr txBox="1"/>
+          <p:nvPr/>
+        </p:nvSpPr>
+        <p:spPr>
+          <a:xfrm>
+            <a:off x="914400" y="457200"/>
+            <a:ext cx="9144000" cy="914400"/>
+          </a:xfrm>
+          <a:prstGeom prst="rect">
+            <a:avLst/>
+          </a:prstGeom>
+          <a:noFill/>
+        </p:spPr>
+        <p:txBody>
+          <a:bodyPr wrap="none">
+            <a:spAutoFit/>
+          </a:bodyPr>
+          <a:lstStyle/>
+          <a:p>
+            <a:r>
+              <a:t>Grouped Image Slide</a:t>
+            </a:r>
+          </a:p>
+        </p:txBody>
+      </p:sp>
+      <p:grpSp>
+        <p:nvGrpSpPr>
+          <p:cNvPr id="99" name="Group 1"/>
+          <p:cNvGrpSpPr/>
+          <p:nvPr/>
+        </p:nvGrpSpPr>
+        <p:grpSpPr>
+          <a:xfrm>
+            <a:off x="0" y="0"/>
+            <a:ext cx="1000000" cy="1000000"/>
+            <a:chOff x="0" y="0"/>
+            <a:chExt cx="1000000" cy="1000000"/>
+          </a:xfrm>
+        </p:grpSpPr>
+        <p:pic>
+          <p:nvPicPr>
+            <p:cNvPr id="4" name="Green Square" descr="test_green.png"/>
+            <p:cNvPicPr>
+              <a:picLocks noChangeAspect="1"/>
+            </p:cNvPicPr>
+            <p:nvPr/>
+          </p:nvPicPr>
+          <p:blipFill>
+            <a:blip r:embed="rId2"/>
+            <a:stretch>
+              <a:fillRect/>
+            </a:stretch>
+          </p:blipFill>
+          <p:spPr>
+            <a:xfrm>
+              <a:off x="1828800" y="1828800"/>
+              <a:ext cx="1828800" cy="1828800"/>
+            </a:xfrm>
+            <a:prstGeom prst="rect">
+              <a:avLst/>
+            </a:prstGeom>
+          </p:spPr>
+        </p:pic>
+      </p:grpSp>
     </p:spTree>
   </p:cSld>
   <p:clrMapOvr>

</xml_diff>